<commit_message>
System Design 101 (vi): sd-11-049 deck terms slide spells out AWS
Co-Authored-By: Claude Sonnet 5.5 <noreply@anthropic.com>
Claude-Session: https://claude.ai/code/session_01MF1cUkoXgxEMeDan8VPPYR
</commit_message>
<xml_diff>
--- a/system-design-101/vi/lessons/sd-11-049/slides/sd-11-049.pptx
+++ b/system-design-101/vi/lessons/sd-11-049/slides/sd-11-049.pptx
@@ -10872,7 +10872,7 @@
         <p:spPr>
           <a:xfrm>
             <a:off x="3238500" y="1885950"/>
-            <a:ext cx="5905500" cy="571500"/>
+            <a:ext cx="5905500" cy="857250"/>
           </a:xfrm>
           <a:prstGeom prst="rect">
             <a:avLst/>
@@ -10888,7 +10888,7 @@
               <a:buNone/>
             </a:pPr>
             <a:r>
-              <a:rPr lang="en-US" sz="2100" dirty="0" spc="2" kern="0">
+              <a:rPr lang="en-US" sz="2100" dirty="0" spc="-4" kern="0">
                 <a:solidFill>
                   <a:srgbClr val="F3EEE3"/>
                 </a:solidFill>
@@ -10896,7 +10896,40 @@
                 <a:ea typeface="Be Vietnam Pro" pitchFamily="34" charset="-122"/>
                 <a:cs typeface="Be Vietnam Pro" pitchFamily="34" charset="-120"/>
               </a:rPr>
-              <a:t>Dịch</a:t>
+              <a:t>Amazon</a:t>
+            </a:r>
+            <a:r>
+              <a:rPr lang="en-US" sz="2100" dirty="0" spc="-27" kern="0">
+                <a:solidFill>
+                  <a:srgbClr val="F3EEE3"/>
+                </a:solidFill>
+                <a:latin typeface="Be Vietnam Pro" pitchFamily="34" charset="0"/>
+                <a:ea typeface="Be Vietnam Pro" pitchFamily="34" charset="-122"/>
+                <a:cs typeface="Be Vietnam Pro" pitchFamily="34" charset="-120"/>
+              </a:rPr>
+              <a:t> Web</a:t>
+            </a:r>
+            <a:r>
+              <a:rPr lang="en-US" sz="2100" dirty="0" spc="-1" kern="0">
+                <a:solidFill>
+                  <a:srgbClr val="F3EEE3"/>
+                </a:solidFill>
+                <a:latin typeface="Be Vietnam Pro" pitchFamily="34" charset="0"/>
+                <a:ea typeface="Be Vietnam Pro" pitchFamily="34" charset="-122"/>
+                <a:cs typeface="Be Vietnam Pro" pitchFamily="34" charset="-120"/>
+              </a:rPr>
+              <a:t> Services:</a:t>
+            </a:r>
+            <a:r>
+              <a:rPr lang="en-US" sz="2100" dirty="0" spc="-2" kern="0">
+                <a:solidFill>
+                  <a:srgbClr val="F3EEE3"/>
+                </a:solidFill>
+                <a:latin typeface="Be Vietnam Pro" pitchFamily="34" charset="0"/>
+                <a:ea typeface="Be Vietnam Pro" pitchFamily="34" charset="-122"/>
+                <a:cs typeface="Be Vietnam Pro" pitchFamily="34" charset="-120"/>
+              </a:rPr>
+              <a:t> dịch</a:t>
             </a:r>
             <a:r>
               <a:rPr lang="en-US" sz="2100" dirty="0" spc="-1" kern="0">

</xml_diff>

<commit_message>
System Design 101 (vi): sd-11-049 title names the introduction page and its two sections
Co-Authored-By: Claude Sonnet 5.5 <noreply@anthropic.com>
Claude-Session: https://claude.ai/code/session_01MF1cUkoXgxEMeDan8VPPYR
</commit_message>
<xml_diff>
--- a/system-design-101/vi/lessons/sd-11-049/slides/sd-11-049.pptx
+++ b/system-design-101/vi/lessons/sd-11-049/slides/sd-11-049.pptx
@@ -2060,6 +2060,17 @@
               <a:t>trang</a:t>
             </a:r>
             <a:r>
+              <a:rPr lang="en-US" sz="3300" b="1" dirty="0" spc="5" kern="0">
+                <a:solidFill>
+                  <a:srgbClr val="F3EEE3"/>
+                </a:solidFill>
+                <a:latin typeface="Be Vietnam Pro" pitchFamily="34" charset="0"/>
+                <a:ea typeface="Be Vietnam Pro" pitchFamily="34" charset="-122"/>
+                <a:cs typeface="Be Vietnam Pro" pitchFamily="34" charset="-120"/>
+              </a:rPr>
+              <a:t> giới</a:t>
+            </a:r>
+            <a:r>
               <a:rPr lang="en-US" sz="3300" b="1" dirty="0" spc="-1" kern="0">
                 <a:solidFill>
                   <a:srgbClr val="F3EEE3"/>
@@ -2068,29 +2079,7 @@
                 <a:ea typeface="Be Vietnam Pro" pitchFamily="34" charset="-122"/>
                 <a:cs typeface="Be Vietnam Pro" pitchFamily="34" charset="-120"/>
               </a:rPr>
-              <a:t> dịch</a:t>
-            </a:r>
-            <a:r>
-              <a:rPr lang="en-US" sz="3300" b="1" dirty="0" spc="-4" kern="0">
-                <a:solidFill>
-                  <a:srgbClr val="F3EEE3"/>
-                </a:solidFill>
-                <a:latin typeface="Be Vietnam Pro" pitchFamily="34" charset="0"/>
-                <a:ea typeface="Be Vietnam Pro" pitchFamily="34" charset="-122"/>
-                <a:cs typeface="Be Vietnam Pro" pitchFamily="34" charset="-120"/>
-              </a:rPr>
-              <a:t> vụ</a:t>
-            </a:r>
-            <a:r>
-              <a:rPr lang="en-US" sz="3300" b="1" dirty="0" spc="-1" kern="0">
-                <a:solidFill>
-                  <a:srgbClr val="F3EEE3"/>
-                </a:solidFill>
-                <a:latin typeface="Be Vietnam Pro" pitchFamily="34" charset="0"/>
-                <a:ea typeface="Be Vietnam Pro" pitchFamily="34" charset="-122"/>
-                <a:cs typeface="Be Vietnam Pro" pitchFamily="34" charset="-120"/>
-              </a:rPr>
-              <a:t> khác</a:t>
+              <a:t> thiệu</a:t>
             </a:r>
             <a:endParaRPr lang="en-US" sz="3300" dirty="0"/>
           </a:p>

</xml_diff>

<commit_message>
System Design 101 (vi): sd-11-049 keep Other services and Miscellaneous separate in the hook, table and deck
Co-Authored-By: Claude Sonnet 5.5 <noreply@anthropic.com>
Claude-Session: https://claude.ai/code/session_01MF1cUkoXgxEMeDan8VPPYR
</commit_message>
<xml_diff>
--- a/system-design-101/vi/lessons/sd-11-049/slides/sd-11-049.pptx
+++ b/system-design-101/vi/lessons/sd-11-049/slides/sd-11-049.pptx
@@ -2347,7 +2347,7 @@
               <a:buNone/>
             </a:pPr>
             <a:r>
-              <a:rPr lang="en-US" sz="2250" dirty="0" spc="5" kern="0">
+              <a:rPr lang="en-US" sz="2250" dirty="0" spc="-38" kern="0">
                 <a:solidFill>
                   <a:srgbClr val="14161C"/>
                 </a:solidFill>
@@ -2355,10 +2355,10 @@
                 <a:ea typeface="Be Vietnam Pro SemiBold" pitchFamily="34" charset="-122"/>
                 <a:cs typeface="Be Vietnam Pro SemiBold" pitchFamily="34" charset="-120"/>
               </a:rPr>
-              <a:t>Giới</a:t>
-            </a:r>
-            <a:r>
-              <a:rPr lang="en-US" sz="2250" dirty="0" spc="0" kern="0">
+              <a:t>Trang</a:t>
+            </a:r>
+            <a:r>
+              <a:rPr lang="en-US" sz="2250" dirty="0" spc="4" kern="0">
                 <a:solidFill>
                   <a:srgbClr val="14161C"/>
                 </a:solidFill>
@@ -2366,10 +2366,10 @@
                 <a:ea typeface="Be Vietnam Pro SemiBold" pitchFamily="34" charset="-122"/>
                 <a:cs typeface="Be Vietnam Pro SemiBold" pitchFamily="34" charset="-120"/>
               </a:rPr>
-              <a:t> thiệu</a:t>
-            </a:r>
-            <a:r>
-              <a:rPr lang="en-US" sz="2250" dirty="0" spc="1" kern="0">
+              <a:t> giới</a:t>
+            </a:r>
+            <a:r>
+              <a:rPr lang="en-US" sz="2250" dirty="0" spc="0" kern="0">
                 <a:solidFill>
                   <a:srgbClr val="14161C"/>
                 </a:solidFill>
@@ -2377,29 +2377,7 @@
                 <a:ea typeface="Be Vietnam Pro SemiBold" pitchFamily="34" charset="-122"/>
                 <a:cs typeface="Be Vietnam Pro SemiBold" pitchFamily="34" charset="-120"/>
               </a:rPr>
-              <a:t> (dịch</a:t>
-            </a:r>
-            <a:r>
-              <a:rPr lang="en-US" sz="2250" dirty="0" spc="0" kern="0">
-                <a:solidFill>
-                  <a:srgbClr val="14161C"/>
-                </a:solidFill>
-                <a:latin typeface="Be Vietnam Pro SemiBold" pitchFamily="34" charset="0"/>
-                <a:ea typeface="Be Vietnam Pro SemiBold" pitchFamily="34" charset="-122"/>
-                <a:cs typeface="Be Vietnam Pro SemiBold" pitchFamily="34" charset="-120"/>
-              </a:rPr>
-              <a:t> vụ</a:t>
-            </a:r>
-            <a:r>
-              <a:rPr lang="en-US" sz="2250" dirty="0" spc="1" kern="0">
-                <a:solidFill>
-                  <a:srgbClr val="14161C"/>
-                </a:solidFill>
-                <a:latin typeface="Be Vietnam Pro SemiBold" pitchFamily="34" charset="0"/>
-                <a:ea typeface="Be Vietnam Pro SemiBold" pitchFamily="34" charset="-122"/>
-                <a:cs typeface="Be Vietnam Pro SemiBold" pitchFamily="34" charset="-120"/>
-              </a:rPr>
-              <a:t> khác)</a:t>
+              <a:t> thiệu</a:t>
             </a:r>
             <a:endParaRPr lang="en-US" sz="2250" dirty="0"/>
           </a:p>

</xml_diff>

<commit_message>
System Design 101 (vi): sd-11-049 deck answer slide names both sections and the rows-not-services caveat
Co-Authored-By: Claude Sonnet 5.5 <noreply@anthropic.com>
Claude-Session: https://claude.ai/code/session_01MF1cUkoXgxEMeDan8VPPYR
</commit_message>
<xml_diff>
--- a/system-design-101/vi/lessons/sd-11-049/slides/sd-11-049.pptx
+++ b/system-design-101/vi/lessons/sd-11-049/slides/sd-11-049.pptx
@@ -8617,7 +8617,7 @@
               <a:t> 194</a:t>
             </a:r>
             <a:r>
-              <a:rPr lang="en-US" sz="2700" b="1" dirty="0" spc="-9" kern="0">
+              <a:rPr lang="en-US" sz="2700" b="1" dirty="0" spc="-6" kern="0">
                 <a:solidFill>
                   <a:srgbClr val="F3EEE3"/>
                 </a:solidFill>
@@ -8625,10 +8625,10 @@
                 <a:ea typeface="Be Vietnam Pro" pitchFamily="34" charset="-122"/>
                 <a:cs typeface="Be Vietnam Pro" pitchFamily="34" charset="-120"/>
               </a:rPr>
-              <a:t> dòng</a:t>
-            </a:r>
-            <a:r>
-              <a:rPr lang="en-US" sz="2700" b="1" dirty="0" spc="-3" kern="0">
+              <a:t> dòng:</a:t>
+            </a:r>
+            <a:r>
+              <a:rPr lang="en-US" sz="2700" b="1" dirty="0" spc="-4" kern="0">
                 <a:solidFill>
                   <a:srgbClr val="F3EEE3"/>
                 </a:solidFill>
@@ -8636,7 +8636,7 @@
                 <a:ea typeface="Be Vietnam Pro" pitchFamily="34" charset="-122"/>
                 <a:cs typeface="Be Vietnam Pro" pitchFamily="34" charset="-120"/>
               </a:rPr>
-              <a:t> nằm</a:t>
+              <a:t> Other</a:t>
             </a:r>
             <a:r>
               <a:rPr lang="en-US" sz="2700" b="1" dirty="0" spc="-1" kern="0">
@@ -8647,10 +8647,10 @@
                 <a:ea typeface="Be Vietnam Pro" pitchFamily="34" charset="-122"/>
                 <a:cs typeface="Be Vietnam Pro" pitchFamily="34" charset="-120"/>
               </a:rPr>
-              <a:t> ở</a:t>
-            </a:r>
-            <a:r>
-              <a:rPr lang="en-US" sz="2700" b="1" dirty="0" spc="-7" kern="0">
+              <a:t> services</a:t>
+            </a:r>
+            <a:r>
+              <a:rPr lang="en-US" sz="2700" b="1" dirty="0" spc="0" kern="0">
                 <a:solidFill>
                   <a:srgbClr val="F3EEE3"/>
                 </a:solidFill>
@@ -8658,7 +8658,18 @@
                 <a:ea typeface="Be Vietnam Pro" pitchFamily="34" charset="-122"/>
                 <a:cs typeface="Be Vietnam Pro" pitchFamily="34" charset="-120"/>
               </a:rPr>
-              <a:t> nhóm</a:t>
+              <a:t> 53,</a:t>
+            </a:r>
+            <a:r>
+              <a:rPr lang="en-US" sz="2700" b="1" dirty="0" spc="-5" kern="0">
+                <a:solidFill>
+                  <a:srgbClr val="F3EEE3"/>
+                </a:solidFill>
+                <a:latin typeface="Be Vietnam Pro" pitchFamily="34" charset="0"/>
+                <a:ea typeface="Be Vietnam Pro" pitchFamily="34" charset="-122"/>
+                <a:cs typeface="Be Vietnam Pro" pitchFamily="34" charset="-120"/>
+              </a:rPr>
+              <a:t> Miscellaneous</a:t>
             </a:r>
             <a:r>
               <a:rPr lang="en-US" sz="2700" b="1" dirty="0" spc="1" kern="0">
@@ -8669,7 +8680,7 @@
                 <a:ea typeface="Be Vietnam Pro" pitchFamily="34" charset="-122"/>
                 <a:cs typeface="Be Vietnam Pro" pitchFamily="34" charset="-120"/>
               </a:rPr>
-              <a:t> khác</a:t>
+              <a:t> 10</a:t>
             </a:r>
             <a:endParaRPr lang="en-US" sz="2700" dirty="0"/>
           </a:p>
@@ -8959,7 +8970,7 @@
               <a:buNone/>
             </a:pPr>
             <a:r>
-              <a:rPr lang="en-US" sz="2400" dirty="0" spc="-3" kern="0">
+              <a:rPr lang="en-US" sz="2400" dirty="0" spc="-4" kern="0">
                 <a:solidFill>
                   <a:srgbClr val="FFB454"/>
                 </a:solidFill>
@@ -8967,10 +8978,10 @@
                 <a:ea typeface="Be Vietnam Pro SemiBold" pitchFamily="34" charset="-122"/>
                 <a:cs typeface="Be Vietnam Pro SemiBold" pitchFamily="34" charset="-120"/>
               </a:rPr>
-              <a:t>Suy</a:t>
-            </a:r>
-            <a:r>
-              <a:rPr lang="en-US" sz="2400" dirty="0" spc="0" kern="0">
+              <a:t>Đếm</a:t>
+            </a:r>
+            <a:r>
+              <a:rPr lang="en-US" sz="2400" dirty="0" spc="-5" kern="0">
                 <a:solidFill>
                   <a:srgbClr val="FFB454"/>
                 </a:solidFill>
@@ -8978,10 +8989,10 @@
                 <a:ea typeface="Be Vietnam Pro SemiBold" pitchFamily="34" charset="-122"/>
                 <a:cs typeface="Be Vietnam Pro SemiBold" pitchFamily="34" charset="-120"/>
               </a:rPr>
-              <a:t> luận</a:t>
-            </a:r>
-            <a:r>
-              <a:rPr lang="en-US" sz="2400" dirty="0" spc="2" kern="0">
+              <a:t> dòng,</a:t>
+            </a:r>
+            <a:r>
+              <a:rPr lang="en-US" sz="2400" dirty="0" spc="-4" kern="0">
                 <a:solidFill>
                   <a:srgbClr val="FFB454"/>
                 </a:solidFill>
@@ -8989,10 +9000,10 @@
                 <a:ea typeface="Be Vietnam Pro SemiBold" pitchFamily="34" charset="-122"/>
                 <a:cs typeface="Be Vietnam Pro SemiBold" pitchFamily="34" charset="-120"/>
               </a:rPr>
-              <a:t> từ</a:t>
-            </a:r>
-            <a:r>
-              <a:rPr lang="en-US" sz="2400" dirty="0" spc="-8" kern="0">
+              <a:t> không</a:t>
+            </a:r>
+            <a:r>
+              <a:rPr lang="en-US" sz="2400" dirty="0" spc="4" kern="0">
                 <a:solidFill>
                   <a:srgbClr val="FFB454"/>
                 </a:solidFill>
@@ -9000,10 +9011,10 @@
                 <a:ea typeface="Be Vietnam Pro SemiBold" pitchFamily="34" charset="-122"/>
                 <a:cs typeface="Be Vietnam Pro SemiBold" pitchFamily="34" charset="-120"/>
               </a:rPr>
-              <a:t> một</a:t>
-            </a:r>
-            <a:r>
-              <a:rPr lang="en-US" sz="2400" dirty="0" spc="0" kern="0">
+              <a:t> đếm</a:t>
+            </a:r>
+            <a:r>
+              <a:rPr lang="en-US" sz="2400" dirty="0" spc="2" kern="0">
                 <a:solidFill>
                   <a:srgbClr val="FFB454"/>
                 </a:solidFill>
@@ -9011,7 +9022,7 @@
                 <a:ea typeface="Be Vietnam Pro SemiBold" pitchFamily="34" charset="-122"/>
                 <a:cs typeface="Be Vietnam Pro SemiBold" pitchFamily="34" charset="-120"/>
               </a:rPr>
-              <a:t> cách</a:t>
+              <a:t> dịch</a:t>
             </a:r>
             <a:r>
               <a:rPr lang="en-US" sz="2400" dirty="0" spc="-1" kern="0">
@@ -9022,10 +9033,10 @@
                 <a:ea typeface="Be Vietnam Pro SemiBold" pitchFamily="34" charset="-122"/>
                 <a:cs typeface="Be Vietnam Pro SemiBold" pitchFamily="34" charset="-120"/>
               </a:rPr>
-              <a:t> chia,</a:t>
-            </a:r>
-            <a:r>
-              <a:rPr lang="en-US" sz="2400" dirty="0" spc="-4" kern="0">
+              <a:t> vụ;</a:t>
+            </a:r>
+            <a:r>
+              <a:rPr lang="en-US" sz="2400" dirty="0" spc="2" kern="0">
                 <a:solidFill>
                   <a:srgbClr val="FFB454"/>
                 </a:solidFill>
@@ -9033,7 +9044,7 @@
                 <a:ea typeface="Be Vietnam Pro SemiBold" pitchFamily="34" charset="-122"/>
                 <a:cs typeface="Be Vietnam Pro SemiBold" pitchFamily="34" charset="-120"/>
               </a:rPr>
-              <a:t> không</a:t>
+              <a:t> chỉ</a:t>
             </a:r>
             <a:r>
               <a:rPr lang="en-US" sz="2400" dirty="0" spc="-3" kern="0">
@@ -9044,10 +9055,43 @@
                 <a:ea typeface="Be Vietnam Pro SemiBold" pitchFamily="34" charset="-122"/>
                 <a:cs typeface="Be Vietnam Pro SemiBold" pitchFamily="34" charset="-120"/>
               </a:rPr>
-              <a:t> phải</a:t>
-            </a:r>
-            <a:r>
-              <a:rPr lang="en-US" sz="2400" dirty="0" spc="-2" kern="0">
+              <a:t> là</a:t>
+            </a:r>
+            <a:r>
+              <a:rPr lang="en-US" sz="2400" dirty="0" spc="-1" kern="0">
+                <a:solidFill>
+                  <a:srgbClr val="FFB454"/>
+                </a:solidFill>
+                <a:latin typeface="Be Vietnam Pro SemiBold" pitchFamily="34" charset="0"/>
+                <a:ea typeface="Be Vietnam Pro SemiBold" pitchFamily="34" charset="-122"/>
+                <a:cs typeface="Be Vietnam Pro SemiBold" pitchFamily="34" charset="-120"/>
+              </a:rPr>
+              <a:t> suy</a:t>
+            </a:r>
+            <a:r>
+              <a:rPr lang="en-US" sz="2400" dirty="0" spc="0" kern="0">
+                <a:solidFill>
+                  <a:srgbClr val="FFB454"/>
+                </a:solidFill>
+                <a:latin typeface="Be Vietnam Pro SemiBold" pitchFamily="34" charset="0"/>
+                <a:ea typeface="Be Vietnam Pro SemiBold" pitchFamily="34" charset="-122"/>
+                <a:cs typeface="Be Vietnam Pro SemiBold" pitchFamily="34" charset="-120"/>
+              </a:rPr>
+              <a:t> luận,</a:t>
+            </a:r>
+            <a:r>
+              <a:rPr lang="en-US" sz="2400" dirty="0" spc="-4" kern="0">
+                <a:solidFill>
+                  <a:srgbClr val="FFB454"/>
+                </a:solidFill>
+                <a:latin typeface="Be Vietnam Pro SemiBold" pitchFamily="34" charset="0"/>
+                <a:ea typeface="Be Vietnam Pro SemiBold" pitchFamily="34" charset="-122"/>
+                <a:cs typeface="Be Vietnam Pro SemiBold" pitchFamily="34" charset="-120"/>
+              </a:rPr>
+              <a:t> không phải</a:t>
+            </a:r>
+            <a:r>
+              <a:rPr lang="en-US" sz="2400" dirty="0" spc="-1" kern="0">
                 <a:solidFill>
                   <a:srgbClr val="FFB454"/>
                 </a:solidFill>

</xml_diff>